<commit_message>
Add learning journal assignment and related documentation for Tag 1
</commit_message>
<xml_diff>
--- a/praesentationen/kurs-einfuehrung.pptx
+++ b/praesentationen/kurs-einfuehrung.pptx
@@ -5,21 +5,22 @@
     <p:sldMasterId id="2147483648" r:id="rId1"/>
   </p:sldMasterIdLst>
   <p:notesMasterIdLst>
-    <p:notesMasterId r:id="rId14"/>
+    <p:notesMasterId r:id="rId15"/>
   </p:notesMasterIdLst>
   <p:sldIdLst>
     <p:sldId id="256" r:id="rId2"/>
     <p:sldId id="257" r:id="rId3"/>
     <p:sldId id="269" r:id="rId4"/>
     <p:sldId id="266" r:id="rId5"/>
-    <p:sldId id="258" r:id="rId6"/>
-    <p:sldId id="259" r:id="rId7"/>
-    <p:sldId id="260" r:id="rId8"/>
-    <p:sldId id="261" r:id="rId9"/>
-    <p:sldId id="262" r:id="rId10"/>
-    <p:sldId id="263" r:id="rId11"/>
-    <p:sldId id="264" r:id="rId12"/>
-    <p:sldId id="265" r:id="rId13"/>
+    <p:sldId id="270" r:id="rId6"/>
+    <p:sldId id="258" r:id="rId7"/>
+    <p:sldId id="259" r:id="rId8"/>
+    <p:sldId id="260" r:id="rId9"/>
+    <p:sldId id="261" r:id="rId10"/>
+    <p:sldId id="262" r:id="rId11"/>
+    <p:sldId id="263" r:id="rId12"/>
+    <p:sldId id="264" r:id="rId13"/>
+    <p:sldId id="265" r:id="rId14"/>
   </p:sldIdLst>
   <p:sldSz cx="12192000" cy="6858000"/>
   <p:notesSz cx="6858000" cy="12192000"/>
@@ -124,6 +125,7 @@
             <p14:sldId id="257"/>
             <p14:sldId id="269"/>
             <p14:sldId id="266"/>
+            <p14:sldId id="270"/>
           </p14:sldIdLst>
         </p14:section>
         <p14:section name="Ziel" id="{FE7FE99F-6FD8-595F-9C95-20DDC4896F53}">
@@ -432,7 +434,7 @@
           <a:p>
             <a:fld id="{F7021451-1387-4CA6-816F-3879F97B5CBC}" type="slidenum">
               <a:rPr lang="en-US"/>
-              <a:t>12</a:t>
+              <a:t>13</a:t>
             </a:fld>
             <a:endParaRPr lang="en-US"/>
           </a:p>
@@ -606,7 +608,7 @@
           <a:p>
             <a:fld id="{F7021451-1387-4CA6-816F-3879F97B5CBC}" type="slidenum">
               <a:rPr lang="en-US"/>
-              <a:t>5</a:t>
+              <a:t>6</a:t>
             </a:fld>
             <a:endParaRPr lang="en-US"/>
           </a:p>
@@ -693,7 +695,7 @@
           <a:p>
             <a:fld id="{F7021451-1387-4CA6-816F-3879F97B5CBC}" type="slidenum">
               <a:rPr lang="en-US"/>
-              <a:t>6</a:t>
+              <a:t>7</a:t>
             </a:fld>
             <a:endParaRPr lang="en-US"/>
           </a:p>
@@ -780,7 +782,7 @@
           <a:p>
             <a:fld id="{F7021451-1387-4CA6-816F-3879F97B5CBC}" type="slidenum">
               <a:rPr lang="en-US"/>
-              <a:t>7</a:t>
+              <a:t>8</a:t>
             </a:fld>
             <a:endParaRPr lang="en-US"/>
           </a:p>
@@ -867,7 +869,7 @@
           <a:p>
             <a:fld id="{F7021451-1387-4CA6-816F-3879F97B5CBC}" type="slidenum">
               <a:rPr lang="en-US"/>
-              <a:t>8</a:t>
+              <a:t>9</a:t>
             </a:fld>
             <a:endParaRPr lang="en-US"/>
           </a:p>
@@ -954,7 +956,7 @@
           <a:p>
             <a:fld id="{F7021451-1387-4CA6-816F-3879F97B5CBC}" type="slidenum">
               <a:rPr lang="en-US"/>
-              <a:t>9</a:t>
+              <a:t>10</a:t>
             </a:fld>
             <a:endParaRPr lang="en-US"/>
           </a:p>
@@ -1041,7 +1043,7 @@
           <a:p>
             <a:fld id="{F7021451-1387-4CA6-816F-3879F97B5CBC}" type="slidenum">
               <a:rPr lang="en-US"/>
-              <a:t>10</a:t>
+              <a:t>11</a:t>
             </a:fld>
             <a:endParaRPr lang="en-US"/>
           </a:p>
@@ -1128,7 +1130,7 @@
           <a:p>
             <a:fld id="{F7021451-1387-4CA6-816F-3879F97B5CBC}" type="slidenum">
               <a:rPr lang="en-US"/>
-              <a:t>11</a:t>
+              <a:t>12</a:t>
             </a:fld>
             <a:endParaRPr lang="en-US"/>
           </a:p>
@@ -1685,7 +1687,7 @@
           </a:prstGeom>
           <a:extLst>
             <a:ext uri="{C572A759-6A51-4108-AA02-DFA0A04FC94B}">
-              <ma14:wrappingTextBoxFlag xmlns:ma14="http://schemas.microsoft.com/office/mac/drawingml/2011/main" xmlns="" val="0"/>
+              <ma14:wrappingTextBoxFlag xmlns="" xmlns:ma14="http://schemas.microsoft.com/office/mac/drawingml/2011/main" val="0"/>
             </a:ext>
           </a:extLst>
         </p:spPr>
@@ -1899,7 +1901,7 @@
           </a:prstGeom>
           <a:extLst>
             <a:ext uri="{C572A759-6A51-4108-AA02-DFA0A04FC94B}">
-              <ma14:wrappingTextBoxFlag xmlns:ma14="http://schemas.microsoft.com/office/mac/drawingml/2011/main" xmlns="" val="0"/>
+              <ma14:wrappingTextBoxFlag xmlns="" xmlns:ma14="http://schemas.microsoft.com/office/mac/drawingml/2011/main" val="0"/>
             </a:ext>
           </a:extLst>
         </p:spPr>
@@ -2295,6 +2297,784 @@
 
 <file path=ppt/slides/slide10.xml><?xml version="1.0" encoding="utf-8"?>
 <p:sld xmlns:a="http://schemas.openxmlformats.org/drawingml/2006/main" xmlns:r="http://schemas.openxmlformats.org/officeDocument/2006/relationships" xmlns:p="http://schemas.openxmlformats.org/presentationml/2006/main">
+  <p:cSld name="Slide 7">
+    <p:spTree>
+      <p:nvGrpSpPr>
+        <p:cNvPr id="1" name=""/>
+        <p:cNvGrpSpPr/>
+        <p:nvPr/>
+      </p:nvGrpSpPr>
+      <p:grpSpPr>
+        <a:xfrm>
+          <a:off x="0" y="0"/>
+          <a:ext cx="0" cy="0"/>
+          <a:chOff x="0" y="0"/>
+          <a:chExt cx="0" cy="0"/>
+        </a:xfrm>
+      </p:grpSpPr>
+      <p:sp>
+        <p:nvSpPr>
+          <p:cNvPr id="2" name="Text 1"/>
+          <p:cNvSpPr>
+            <a:spLocks noGrp="1"/>
+          </p:cNvSpPr>
+          <p:nvPr>
+            <p:ph type="title" idx="102" hasCustomPrompt="1"/>
+          </p:nvPr>
+        </p:nvSpPr>
+        <p:spPr>
+          <a:xfrm>
+            <a:off x="548640" y="320040"/>
+            <a:ext cx="11094415" cy="822960"/>
+          </a:xfrm>
+          <a:prstGeom prst="rect">
+            <a:avLst/>
+          </a:prstGeom>
+          <a:noFill/>
+          <a:ln/>
+        </p:spPr>
+        <p:txBody>
+          <a:bodyPr wrap="square" lIns="0" tIns="0" rIns="0" bIns="0" rtlCol="0" anchor="ctr"/>
+          <a:lstStyle/>
+          <a:p>
+            <a:pPr marL="0" indent="0" algn="l">
+              <a:buNone/>
+            </a:pPr>
+            <a:r>
+              <a:rPr lang="en-US" sz="3400" b="1" dirty="0">
+                <a:solidFill>
+                  <a:srgbClr val="27303A"/>
+                </a:solidFill>
+              </a:rPr>
+              <a:t>So arbeiten wir</a:t>
+            </a:r>
+            <a:endParaRPr lang="en-US" sz="3400" dirty="0"/>
+          </a:p>
+        </p:txBody>
+      </p:sp>
+      <p:sp>
+        <p:nvSpPr>
+          <p:cNvPr id="3" name="karte"/>
+          <p:cNvSpPr/>
+          <p:nvPr/>
+        </p:nvSpPr>
+        <p:spPr>
+          <a:xfrm>
+            <a:off x="548640" y="1325880"/>
+            <a:ext cx="5410048" cy="2217420"/>
+          </a:xfrm>
+          <a:prstGeom prst="roundRect">
+            <a:avLst>
+              <a:gd name="adj" fmla="val 4948"/>
+            </a:avLst>
+          </a:prstGeom>
+          <a:solidFill>
+            <a:srgbClr val="F7F7F7"/>
+          </a:solidFill>
+          <a:ln w="12700">
+            <a:solidFill>
+              <a:srgbClr val="F7F7F7"/>
+            </a:solidFill>
+            <a:prstDash val="solid"/>
+          </a:ln>
+        </p:spPr>
+        <p:txBody>
+          <a:bodyPr/>
+          <a:lstStyle/>
+          <a:p>
+            <a:endParaRPr lang="de-DE"/>
+          </a:p>
+        </p:txBody>
+      </p:sp>
+      <p:sp>
+        <p:nvSpPr>
+          <p:cNvPr id="4" name="icon-kreis-FaPencilAlt"/>
+          <p:cNvSpPr/>
+          <p:nvPr/>
+        </p:nvSpPr>
+        <p:spPr>
+          <a:xfrm>
+            <a:off x="822960" y="1600200"/>
+            <a:ext cx="640080" cy="640080"/>
+          </a:xfrm>
+          <a:prstGeom prst="ellipse">
+            <a:avLst/>
+          </a:prstGeom>
+          <a:solidFill>
+            <a:srgbClr val="006FAD"/>
+          </a:solidFill>
+          <a:ln w="12700">
+            <a:solidFill>
+              <a:srgbClr val="006FAD"/>
+            </a:solidFill>
+            <a:prstDash val="solid"/>
+          </a:ln>
+        </p:spPr>
+        <p:txBody>
+          <a:bodyPr/>
+          <a:lstStyle/>
+          <a:p>
+            <a:endParaRPr lang="de-DE"/>
+          </a:p>
+        </p:txBody>
+      </p:sp>
+      <p:pic>
+        <p:nvPicPr>
+          <p:cNvPr id="5" name="icon-FaPencilAlt" descr="C:\Users\Thanam\AppData\Local\Temp\claude\c--Projekt-Trainings-azure-basics-training\a7a6b8eb-22f3-4b42-aecc-5af05d1502b1\scratchpad\folien\assets\icons\FaPencilAlt.png"/>
+          <p:cNvPicPr>
+            <a:picLocks noChangeAspect="1"/>
+          </p:cNvPicPr>
+          <p:nvPr/>
+        </p:nvPicPr>
+        <p:blipFill>
+          <a:blip r:embed="rId3"/>
+          <a:stretch>
+            <a:fillRect/>
+          </a:stretch>
+        </p:blipFill>
+        <p:spPr>
+          <a:xfrm>
+            <a:off x="976579" y="1753819"/>
+            <a:ext cx="332842" cy="332842"/>
+          </a:xfrm>
+          <a:prstGeom prst="rect">
+            <a:avLst/>
+          </a:prstGeom>
+        </p:spPr>
+      </p:pic>
+      <p:sp>
+        <p:nvSpPr>
+          <p:cNvPr id="6" name="Text 3"/>
+          <p:cNvSpPr txBox="1"/>
+          <p:nvPr/>
+        </p:nvSpPr>
+        <p:spPr>
+          <a:xfrm>
+            <a:off x="1645920" y="1600200"/>
+            <a:ext cx="4084168" cy="640080"/>
+          </a:xfrm>
+          <a:prstGeom prst="rect">
+            <a:avLst/>
+          </a:prstGeom>
+          <a:noFill/>
+          <a:ln/>
+        </p:spPr>
+        <p:txBody>
+          <a:bodyPr wrap="square" lIns="0" tIns="0" rIns="0" bIns="0" rtlCol="0" anchor="ctr">
+            <a:normAutofit/>
+          </a:bodyPr>
+          <a:lstStyle/>
+          <a:p>
+            <a:pPr marL="0" indent="0">
+              <a:buNone/>
+            </a:pPr>
+            <a:r>
+              <a:rPr lang="en-US" sz="2000" b="1" dirty="0">
+                <a:solidFill>
+                  <a:srgbClr val="27303A"/>
+                </a:solidFill>
+              </a:rPr>
+              <a:t>Lernjournal</a:t>
+            </a:r>
+            <a:endParaRPr lang="en-US" sz="2000" dirty="0"/>
+          </a:p>
+        </p:txBody>
+      </p:sp>
+      <p:sp>
+        <p:nvSpPr>
+          <p:cNvPr id="7" name="Text 4"/>
+          <p:cNvSpPr txBox="1"/>
+          <p:nvPr/>
+        </p:nvSpPr>
+        <p:spPr>
+          <a:xfrm>
+            <a:off x="822960" y="2423160"/>
+            <a:ext cx="4861408" cy="982980"/>
+          </a:xfrm>
+          <a:prstGeom prst="rect">
+            <a:avLst/>
+          </a:prstGeom>
+          <a:noFill/>
+          <a:ln/>
+        </p:spPr>
+        <p:txBody>
+          <a:bodyPr wrap="square" lIns="0" tIns="0" rIns="0" bIns="0" rtlCol="0" anchor="t"/>
+          <a:lstStyle/>
+          <a:p>
+            <a:pPr marL="0" indent="0">
+              <a:spcAft>
+                <a:spcPts val="400"/>
+              </a:spcAft>
+              <a:buNone/>
+            </a:pPr>
+            <a:r>
+              <a:rPr lang="en-US" sz="1600" dirty="0">
+                <a:solidFill>
+                  <a:srgbClr val="27303A"/>
+                </a:solidFill>
+              </a:rPr>
+              <a:t>Pro Auftrag: Befehle, Screenshot als Nachweis (ohne persönliche Daten), was nicht geklappt hat.</a:t>
+            </a:r>
+            <a:endParaRPr lang="en-US" sz="1600" dirty="0"/>
+          </a:p>
+        </p:txBody>
+      </p:sp>
+      <p:sp>
+        <p:nvSpPr>
+          <p:cNvPr id="8" name="karte"/>
+          <p:cNvSpPr/>
+          <p:nvPr/>
+        </p:nvSpPr>
+        <p:spPr>
+          <a:xfrm>
+            <a:off x="6233008" y="1325880"/>
+            <a:ext cx="5410048" cy="2217420"/>
+          </a:xfrm>
+          <a:prstGeom prst="roundRect">
+            <a:avLst>
+              <a:gd name="adj" fmla="val 4948"/>
+            </a:avLst>
+          </a:prstGeom>
+          <a:solidFill>
+            <a:srgbClr val="F7F7F7"/>
+          </a:solidFill>
+          <a:ln w="12700">
+            <a:solidFill>
+              <a:srgbClr val="F7F7F7"/>
+            </a:solidFill>
+            <a:prstDash val="solid"/>
+          </a:ln>
+        </p:spPr>
+        <p:txBody>
+          <a:bodyPr/>
+          <a:lstStyle/>
+          <a:p>
+            <a:endParaRPr lang="de-DE"/>
+          </a:p>
+        </p:txBody>
+      </p:sp>
+      <p:sp>
+        <p:nvSpPr>
+          <p:cNvPr id="9" name="icon-kreis-FaUsers"/>
+          <p:cNvSpPr/>
+          <p:nvPr/>
+        </p:nvSpPr>
+        <p:spPr>
+          <a:xfrm>
+            <a:off x="6507328" y="1600200"/>
+            <a:ext cx="640080" cy="640080"/>
+          </a:xfrm>
+          <a:prstGeom prst="ellipse">
+            <a:avLst/>
+          </a:prstGeom>
+          <a:solidFill>
+            <a:srgbClr val="006FAD"/>
+          </a:solidFill>
+          <a:ln w="12700">
+            <a:solidFill>
+              <a:srgbClr val="006FAD"/>
+            </a:solidFill>
+            <a:prstDash val="solid"/>
+          </a:ln>
+        </p:spPr>
+        <p:txBody>
+          <a:bodyPr/>
+          <a:lstStyle/>
+          <a:p>
+            <a:endParaRPr lang="de-DE"/>
+          </a:p>
+        </p:txBody>
+      </p:sp>
+      <p:pic>
+        <p:nvPicPr>
+          <p:cNvPr id="10" name="icon-FaUsers" descr="C:\Users\Thanam\AppData\Local\Temp\claude\c--Projekt-Trainings-azure-basics-training\a7a6b8eb-22f3-4b42-aecc-5af05d1502b1\scratchpad\folien\assets\icons\FaUsers.png"/>
+          <p:cNvPicPr>
+            <a:picLocks noChangeAspect="1"/>
+          </p:cNvPicPr>
+          <p:nvPr/>
+        </p:nvPicPr>
+        <p:blipFill>
+          <a:blip r:embed="rId4"/>
+          <a:stretch>
+            <a:fillRect/>
+          </a:stretch>
+        </p:blipFill>
+        <p:spPr>
+          <a:xfrm>
+            <a:off x="6660947" y="1753819"/>
+            <a:ext cx="332842" cy="332842"/>
+          </a:xfrm>
+          <a:prstGeom prst="rect">
+            <a:avLst/>
+          </a:prstGeom>
+        </p:spPr>
+      </p:pic>
+      <p:sp>
+        <p:nvSpPr>
+          <p:cNvPr id="11" name="Text 7"/>
+          <p:cNvSpPr txBox="1"/>
+          <p:nvPr/>
+        </p:nvSpPr>
+        <p:spPr>
+          <a:xfrm>
+            <a:off x="7330288" y="1600200"/>
+            <a:ext cx="4084168" cy="640080"/>
+          </a:xfrm>
+          <a:prstGeom prst="rect">
+            <a:avLst/>
+          </a:prstGeom>
+          <a:noFill/>
+          <a:ln/>
+        </p:spPr>
+        <p:txBody>
+          <a:bodyPr wrap="square" lIns="0" tIns="0" rIns="0" bIns="0" rtlCol="0" anchor="ctr">
+            <a:normAutofit/>
+          </a:bodyPr>
+          <a:lstStyle/>
+          <a:p>
+            <a:pPr marL="0" indent="0">
+              <a:buNone/>
+            </a:pPr>
+            <a:r>
+              <a:rPr lang="en-US" sz="2000" b="1" dirty="0">
+                <a:solidFill>
+                  <a:srgbClr val="27303A"/>
+                </a:solidFill>
+              </a:rPr>
+              <a:t>Partnerarbeit</a:t>
+            </a:r>
+            <a:endParaRPr lang="en-US" sz="2000" dirty="0"/>
+          </a:p>
+        </p:txBody>
+      </p:sp>
+      <p:sp>
+        <p:nvSpPr>
+          <p:cNvPr id="12" name="Text 8"/>
+          <p:cNvSpPr txBox="1"/>
+          <p:nvPr/>
+        </p:nvSpPr>
+        <p:spPr>
+          <a:xfrm>
+            <a:off x="6507328" y="2423160"/>
+            <a:ext cx="4861408" cy="982980"/>
+          </a:xfrm>
+          <a:prstGeom prst="rect">
+            <a:avLst/>
+          </a:prstGeom>
+          <a:noFill/>
+          <a:ln/>
+        </p:spPr>
+        <p:txBody>
+          <a:bodyPr wrap="square" lIns="0" tIns="0" rIns="0" bIns="0" rtlCol="0" anchor="t"/>
+          <a:lstStyle/>
+          <a:p>
+            <a:pPr marL="0" indent="0">
+              <a:spcAft>
+                <a:spcPts val="400"/>
+              </a:spcAft>
+              <a:buNone/>
+            </a:pPr>
+            <a:r>
+              <a:rPr lang="en-US" sz="1600" dirty="0">
+                <a:solidFill>
+                  <a:srgbClr val="27303A"/>
+                </a:solidFill>
+              </a:rPr>
+              <a:t>Driver tippt, Navigator liest und kontrolliert. Nach jedem Auftrag wechseln.</a:t>
+            </a:r>
+            <a:endParaRPr lang="en-US" sz="1600" dirty="0"/>
+          </a:p>
+        </p:txBody>
+      </p:sp>
+      <p:sp>
+        <p:nvSpPr>
+          <p:cNvPr id="13" name="karte"/>
+          <p:cNvSpPr/>
+          <p:nvPr/>
+        </p:nvSpPr>
+        <p:spPr>
+          <a:xfrm>
+            <a:off x="548640" y="3817620"/>
+            <a:ext cx="5410048" cy="2217420"/>
+          </a:xfrm>
+          <a:prstGeom prst="roundRect">
+            <a:avLst>
+              <a:gd name="adj" fmla="val 4948"/>
+            </a:avLst>
+          </a:prstGeom>
+          <a:solidFill>
+            <a:srgbClr val="F7F7F7"/>
+          </a:solidFill>
+          <a:ln w="12700">
+            <a:solidFill>
+              <a:srgbClr val="F7F7F7"/>
+            </a:solidFill>
+            <a:prstDash val="solid"/>
+          </a:ln>
+        </p:spPr>
+        <p:txBody>
+          <a:bodyPr/>
+          <a:lstStyle/>
+          <a:p>
+            <a:endParaRPr lang="de-DE"/>
+          </a:p>
+        </p:txBody>
+      </p:sp>
+      <p:sp>
+        <p:nvSpPr>
+          <p:cNvPr id="14" name="icon-kreis-FaClock"/>
+          <p:cNvSpPr/>
+          <p:nvPr/>
+        </p:nvSpPr>
+        <p:spPr>
+          <a:xfrm>
+            <a:off x="822960" y="4091940"/>
+            <a:ext cx="640080" cy="640080"/>
+          </a:xfrm>
+          <a:prstGeom prst="ellipse">
+            <a:avLst/>
+          </a:prstGeom>
+          <a:solidFill>
+            <a:srgbClr val="006FAD"/>
+          </a:solidFill>
+          <a:ln w="12700">
+            <a:solidFill>
+              <a:srgbClr val="006FAD"/>
+            </a:solidFill>
+            <a:prstDash val="solid"/>
+          </a:ln>
+        </p:spPr>
+        <p:txBody>
+          <a:bodyPr/>
+          <a:lstStyle/>
+          <a:p>
+            <a:endParaRPr lang="de-DE"/>
+          </a:p>
+        </p:txBody>
+      </p:sp>
+      <p:pic>
+        <p:nvPicPr>
+          <p:cNvPr id="15" name="icon-FaClock" descr="C:\Users\Thanam\AppData\Local\Temp\claude\c--Projekt-Trainings-azure-basics-training\a7a6b8eb-22f3-4b42-aecc-5af05d1502b1\scratchpad\folien\assets\icons\FaClock.png"/>
+          <p:cNvPicPr>
+            <a:picLocks noChangeAspect="1"/>
+          </p:cNvPicPr>
+          <p:nvPr/>
+        </p:nvPicPr>
+        <p:blipFill>
+          <a:blip r:embed="rId5"/>
+          <a:stretch>
+            <a:fillRect/>
+          </a:stretch>
+        </p:blipFill>
+        <p:spPr>
+          <a:xfrm>
+            <a:off x="976579" y="4245559"/>
+            <a:ext cx="332842" cy="332842"/>
+          </a:xfrm>
+          <a:prstGeom prst="rect">
+            <a:avLst/>
+          </a:prstGeom>
+        </p:spPr>
+      </p:pic>
+      <p:sp>
+        <p:nvSpPr>
+          <p:cNvPr id="16" name="Text 11"/>
+          <p:cNvSpPr txBox="1"/>
+          <p:nvPr/>
+        </p:nvSpPr>
+        <p:spPr>
+          <a:xfrm>
+            <a:off x="1645920" y="4091940"/>
+            <a:ext cx="4084168" cy="640080"/>
+          </a:xfrm>
+          <a:prstGeom prst="rect">
+            <a:avLst/>
+          </a:prstGeom>
+          <a:noFill/>
+          <a:ln/>
+        </p:spPr>
+        <p:txBody>
+          <a:bodyPr wrap="square" lIns="0" tIns="0" rIns="0" bIns="0" rtlCol="0" anchor="ctr">
+            <a:normAutofit/>
+          </a:bodyPr>
+          <a:lstStyle/>
+          <a:p>
+            <a:pPr marL="0" indent="0">
+              <a:buNone/>
+            </a:pPr>
+            <a:r>
+              <a:rPr lang="en-US" sz="2000" b="1" dirty="0">
+                <a:solidFill>
+                  <a:srgbClr val="27303A"/>
+                </a:solidFill>
+              </a:rPr>
+              <a:t>Hilfe holen</a:t>
+            </a:r>
+            <a:endParaRPr lang="en-US" sz="2000" dirty="0"/>
+          </a:p>
+        </p:txBody>
+      </p:sp>
+      <p:sp>
+        <p:nvSpPr>
+          <p:cNvPr id="17" name="Text 12"/>
+          <p:cNvSpPr txBox="1"/>
+          <p:nvPr/>
+        </p:nvSpPr>
+        <p:spPr>
+          <a:xfrm>
+            <a:off x="822960" y="4914900"/>
+            <a:ext cx="4861408" cy="982980"/>
+          </a:xfrm>
+          <a:prstGeom prst="rect">
+            <a:avLst/>
+          </a:prstGeom>
+          <a:noFill/>
+          <a:ln/>
+        </p:spPr>
+        <p:txBody>
+          <a:bodyPr wrap="square" lIns="0" tIns="0" rIns="0" bIns="0" rtlCol="0" anchor="t"/>
+          <a:lstStyle/>
+          <a:p>
+            <a:pPr marL="0" indent="0">
+              <a:spcAft>
+                <a:spcPts val="400"/>
+              </a:spcAft>
+              <a:buNone/>
+            </a:pPr>
+            <a:r>
+              <a:rPr lang="en-US" sz="1600" dirty="0">
+                <a:solidFill>
+                  <a:srgbClr val="27303A"/>
+                </a:solidFill>
+              </a:rPr>
+              <a:t>10 Minuten selbst probieren, dann Partner fragen, dann Kursleitung.</a:t>
+            </a:r>
+            <a:endParaRPr lang="en-US" sz="1600" dirty="0"/>
+          </a:p>
+        </p:txBody>
+      </p:sp>
+      <p:sp>
+        <p:nvSpPr>
+          <p:cNvPr id="18" name="karte"/>
+          <p:cNvSpPr/>
+          <p:nvPr/>
+        </p:nvSpPr>
+        <p:spPr>
+          <a:xfrm>
+            <a:off x="6233008" y="3817620"/>
+            <a:ext cx="5410048" cy="2217420"/>
+          </a:xfrm>
+          <a:prstGeom prst="roundRect">
+            <a:avLst>
+              <a:gd name="adj" fmla="val 4948"/>
+            </a:avLst>
+          </a:prstGeom>
+          <a:solidFill>
+            <a:srgbClr val="F7F7F7"/>
+          </a:solidFill>
+          <a:ln w="12700">
+            <a:solidFill>
+              <a:srgbClr val="F7F7F7"/>
+            </a:solidFill>
+            <a:prstDash val="solid"/>
+          </a:ln>
+        </p:spPr>
+        <p:txBody>
+          <a:bodyPr/>
+          <a:lstStyle/>
+          <a:p>
+            <a:endParaRPr lang="de-DE"/>
+          </a:p>
+        </p:txBody>
+      </p:sp>
+      <p:sp>
+        <p:nvSpPr>
+          <p:cNvPr id="19" name="icon-kreis-FaDoorOpen"/>
+          <p:cNvSpPr/>
+          <p:nvPr/>
+        </p:nvSpPr>
+        <p:spPr>
+          <a:xfrm>
+            <a:off x="6507328" y="4091940"/>
+            <a:ext cx="640080" cy="640080"/>
+          </a:xfrm>
+          <a:prstGeom prst="ellipse">
+            <a:avLst/>
+          </a:prstGeom>
+          <a:solidFill>
+            <a:srgbClr val="006FAD"/>
+          </a:solidFill>
+          <a:ln w="12700">
+            <a:solidFill>
+              <a:srgbClr val="006FAD"/>
+            </a:solidFill>
+            <a:prstDash val="solid"/>
+          </a:ln>
+        </p:spPr>
+        <p:txBody>
+          <a:bodyPr/>
+          <a:lstStyle/>
+          <a:p>
+            <a:endParaRPr lang="de-DE"/>
+          </a:p>
+        </p:txBody>
+      </p:sp>
+      <p:pic>
+        <p:nvPicPr>
+          <p:cNvPr id="20" name="icon-FaDoorOpen" descr="C:\Users\Thanam\AppData\Local\Temp\claude\c--Projekt-Trainings-azure-basics-training\a7a6b8eb-22f3-4b42-aecc-5af05d1502b1\scratchpad\folien\assets\icons\FaDoorOpen.png"/>
+          <p:cNvPicPr>
+            <a:picLocks noChangeAspect="1"/>
+          </p:cNvPicPr>
+          <p:nvPr/>
+        </p:nvPicPr>
+        <p:blipFill>
+          <a:blip r:embed="rId6"/>
+          <a:stretch>
+            <a:fillRect/>
+          </a:stretch>
+        </p:blipFill>
+        <p:spPr>
+          <a:xfrm>
+            <a:off x="6660947" y="4245559"/>
+            <a:ext cx="332842" cy="332842"/>
+          </a:xfrm>
+          <a:prstGeom prst="rect">
+            <a:avLst/>
+          </a:prstGeom>
+        </p:spPr>
+      </p:pic>
+      <p:sp>
+        <p:nvSpPr>
+          <p:cNvPr id="21" name="Text 15"/>
+          <p:cNvSpPr txBox="1"/>
+          <p:nvPr/>
+        </p:nvSpPr>
+        <p:spPr>
+          <a:xfrm>
+            <a:off x="7330288" y="4091940"/>
+            <a:ext cx="4084168" cy="640080"/>
+          </a:xfrm>
+          <a:prstGeom prst="rect">
+            <a:avLst/>
+          </a:prstGeom>
+          <a:noFill/>
+          <a:ln/>
+        </p:spPr>
+        <p:txBody>
+          <a:bodyPr wrap="square" lIns="0" tIns="0" rIns="0" bIns="0" rtlCol="0" anchor="ctr">
+            <a:normAutofit/>
+          </a:bodyPr>
+          <a:lstStyle/>
+          <a:p>
+            <a:pPr marL="0" indent="0">
+              <a:buNone/>
+            </a:pPr>
+            <a:r>
+              <a:rPr lang="en-US" sz="2000" b="1" dirty="0">
+                <a:solidFill>
+                  <a:srgbClr val="27303A"/>
+                </a:solidFill>
+              </a:rPr>
+              <a:t>Exit-Ticket</a:t>
+            </a:r>
+            <a:endParaRPr lang="en-US" sz="2000" dirty="0"/>
+          </a:p>
+        </p:txBody>
+      </p:sp>
+      <p:sp>
+        <p:nvSpPr>
+          <p:cNvPr id="22" name="Text 16"/>
+          <p:cNvSpPr txBox="1"/>
+          <p:nvPr/>
+        </p:nvSpPr>
+        <p:spPr>
+          <a:xfrm>
+            <a:off x="6507328" y="4914900"/>
+            <a:ext cx="4861408" cy="982980"/>
+          </a:xfrm>
+          <a:prstGeom prst="rect">
+            <a:avLst/>
+          </a:prstGeom>
+          <a:noFill/>
+          <a:ln/>
+        </p:spPr>
+        <p:txBody>
+          <a:bodyPr wrap="square" lIns="0" tIns="0" rIns="0" bIns="0" rtlCol="0" anchor="t"/>
+          <a:lstStyle/>
+          <a:p>
+            <a:pPr marL="0" indent="0">
+              <a:spcAft>
+                <a:spcPts val="400"/>
+              </a:spcAft>
+              <a:buNone/>
+            </a:pPr>
+            <a:r>
+              <a:rPr lang="en-US" sz="1600" dirty="0">
+                <a:solidFill>
+                  <a:srgbClr val="27303A"/>
+                </a:solidFill>
+              </a:rPr>
+              <a:t>Am Ende jedes Tages eine kurze Frage, 1–3 Sätze. Keine Note.</a:t>
+            </a:r>
+            <a:endParaRPr lang="en-US" sz="1600" dirty="0"/>
+          </a:p>
+        </p:txBody>
+      </p:sp>
+      <p:sp>
+        <p:nvSpPr>
+          <p:cNvPr id="25" name="Slide Number Placeholder 0"/>
+          <p:cNvSpPr>
+            <a:spLocks noGrp="1"/>
+          </p:cNvSpPr>
+          <p:nvPr>
+            <p:ph type="sldNum" sz="quarter" idx="4294967295"/>
+          </p:nvPr>
+        </p:nvSpPr>
+        <p:spPr>
+          <a:xfrm>
+            <a:off x="11183112" y="6336792"/>
+            <a:ext cx="457200" cy="365760"/>
+          </a:xfrm>
+          <a:prstGeom prst="rect">
+            <a:avLst/>
+          </a:prstGeom>
+          <a:extLst>
+            <a:ext uri="{C572A759-6A51-4108-AA02-DFA0A04FC94B}">
+              <ma14:wrappingTextBoxFlag xmlns="" xmlns:ma14="http://schemas.microsoft.com/office/mac/drawingml/2011/main" val="0"/>
+            </a:ext>
+          </a:extLst>
+        </p:spPr>
+        <p:txBody>
+          <a:bodyPr/>
+          <a:lstStyle>
+            <a:lvl1pPr>
+              <a:defRPr sz="1000">
+                <a:solidFill>
+                  <a:srgbClr val="6F6F6F"/>
+                </a:solidFill>
+              </a:defRPr>
+            </a:lvl1pPr>
+          </a:lstStyle>
+          <a:p>
+            <a:pPr algn="r"/>
+            <a:fld id="{F7021451-1387-4CA6-816F-3879F97B5CBC}" type="slidenum">
+              <a:rPr lang="en-US" b="0"/>
+              <a:t>10</a:t>
+            </a:fld>
+            <a:endParaRPr lang="en-US"/>
+          </a:p>
+        </p:txBody>
+      </p:sp>
+    </p:spTree>
+  </p:cSld>
+  <p:clrMapOvr>
+    <a:masterClrMapping/>
+  </p:clrMapOvr>
+</p:sld>
+</file>
+
+<file path=ppt/slides/slide11.xml><?xml version="1.0" encoding="utf-8"?>
+<p:sld xmlns:a="http://schemas.openxmlformats.org/drawingml/2006/main" xmlns:r="http://schemas.openxmlformats.org/officeDocument/2006/relationships" xmlns:p="http://schemas.openxmlformats.org/presentationml/2006/main">
   <p:cSld name="Slide 8">
     <p:spTree>
       <p:nvGrpSpPr>
@@ -2871,7 +3651,7 @@
           </a:prstGeom>
           <a:extLst>
             <a:ext uri="{C572A759-6A51-4108-AA02-DFA0A04FC94B}">
-              <ma14:wrappingTextBoxFlag xmlns:ma14="http://schemas.microsoft.com/office/mac/drawingml/2011/main" xmlns="" val="0"/>
+              <ma14:wrappingTextBoxFlag xmlns="" xmlns:ma14="http://schemas.microsoft.com/office/mac/drawingml/2011/main" val="0"/>
             </a:ext>
           </a:extLst>
         </p:spPr>
@@ -2890,7 +3670,7 @@
             <a:pPr algn="r"/>
             <a:fld id="{F7021451-1387-4CA6-816F-3879F97B5CBC}" type="slidenum">
               <a:rPr lang="en-US" b="0"/>
-              <a:t>10</a:t>
+              <a:t>11</a:t>
             </a:fld>
             <a:endParaRPr lang="en-US"/>
           </a:p>
@@ -2904,7 +3684,7 @@
 </p:sld>
 </file>
 
-<file path=ppt/slides/slide11.xml><?xml version="1.0" encoding="utf-8"?>
+<file path=ppt/slides/slide12.xml><?xml version="1.0" encoding="utf-8"?>
 <p:sld xmlns:a="http://schemas.openxmlformats.org/drawingml/2006/main" xmlns:r="http://schemas.openxmlformats.org/officeDocument/2006/relationships" xmlns:p="http://schemas.openxmlformats.org/presentationml/2006/main">
   <p:cSld name="Slide 9">
     <p:spTree>
@@ -3482,7 +4262,7 @@
           </a:prstGeom>
           <a:extLst>
             <a:ext uri="{C572A759-6A51-4108-AA02-DFA0A04FC94B}">
-              <ma14:wrappingTextBoxFlag xmlns:ma14="http://schemas.microsoft.com/office/mac/drawingml/2011/main" xmlns="" val="0"/>
+              <ma14:wrappingTextBoxFlag xmlns="" xmlns:ma14="http://schemas.microsoft.com/office/mac/drawingml/2011/main" val="0"/>
             </a:ext>
           </a:extLst>
         </p:spPr>
@@ -3501,7 +4281,7 @@
             <a:pPr algn="r"/>
             <a:fld id="{F7021451-1387-4CA6-816F-3879F97B5CBC}" type="slidenum">
               <a:rPr lang="en-US" b="0"/>
-              <a:t>11</a:t>
+              <a:t>12</a:t>
             </a:fld>
             <a:endParaRPr lang="en-US"/>
           </a:p>
@@ -3515,7 +4295,7 @@
 </p:sld>
 </file>
 
-<file path=ppt/slides/slide12.xml><?xml version="1.0" encoding="utf-8"?>
+<file path=ppt/slides/slide13.xml><?xml version="1.0" encoding="utf-8"?>
 <p:sld xmlns:a="http://schemas.openxmlformats.org/drawingml/2006/main" xmlns:r="http://schemas.openxmlformats.org/officeDocument/2006/relationships" xmlns:p="http://schemas.openxmlformats.org/presentationml/2006/main">
   <p:cSld name="Slide 10">
     <p:spTree>
@@ -3685,7 +4465,7 @@
         </p:nvSpPr>
         <p:spPr>
           <a:xfrm>
-            <a:off x="548640" y="2446020"/>
+            <a:off x="1454162" y="2475760"/>
             <a:ext cx="548640" cy="548640"/>
           </a:xfrm>
           <a:prstGeom prst="ellipse">
@@ -3725,7 +4505,7 @@
         </p:blipFill>
         <p:spPr>
           <a:xfrm>
-            <a:off x="680314" y="2577694"/>
+            <a:off x="1585836" y="2607434"/>
             <a:ext cx="285293" cy="285293"/>
           </a:xfrm>
           <a:prstGeom prst="rect">
@@ -3741,8 +4521,8 @@
         </p:nvSpPr>
         <p:spPr>
           <a:xfrm>
-            <a:off x="1325880" y="2240280"/>
-            <a:ext cx="10317175" cy="960120"/>
+            <a:off x="2231403" y="2270020"/>
+            <a:ext cx="5809512" cy="960120"/>
           </a:xfrm>
           <a:prstGeom prst="rect">
             <a:avLst/>
@@ -3791,7 +4571,7 @@
         </p:nvSpPr>
         <p:spPr>
           <a:xfrm>
-            <a:off x="548640" y="3406140"/>
+            <a:off x="1454162" y="3435880"/>
             <a:ext cx="548640" cy="548640"/>
           </a:xfrm>
           <a:prstGeom prst="ellipse">
@@ -3831,7 +4611,7 @@
         </p:blipFill>
         <p:spPr>
           <a:xfrm>
-            <a:off x="680314" y="3537814"/>
+            <a:off x="1585836" y="3567554"/>
             <a:ext cx="285293" cy="285293"/>
           </a:xfrm>
           <a:prstGeom prst="rect">
@@ -3847,8 +4627,8 @@
         </p:nvSpPr>
         <p:spPr>
           <a:xfrm>
-            <a:off x="1325880" y="3200400"/>
-            <a:ext cx="10317175" cy="960120"/>
+            <a:off x="2231403" y="3230140"/>
+            <a:ext cx="5490198" cy="960120"/>
           </a:xfrm>
           <a:prstGeom prst="rect">
             <a:avLst/>
@@ -3891,153 +4671,6 @@
       </p:sp>
       <p:sp>
         <p:nvSpPr>
-          <p:cNvPr id="9" name="icon-kreis-FaFlagCheckered"/>
-          <p:cNvSpPr/>
-          <p:nvPr/>
-        </p:nvSpPr>
-        <p:spPr>
-          <a:xfrm>
-            <a:off x="548640" y="4366260"/>
-            <a:ext cx="548640" cy="548640"/>
-          </a:xfrm>
-          <a:prstGeom prst="ellipse">
-            <a:avLst/>
-          </a:prstGeom>
-          <a:solidFill>
-            <a:srgbClr val="006FAD"/>
-          </a:solidFill>
-          <a:ln w="12700">
-            <a:solidFill>
-              <a:srgbClr val="006FAD"/>
-            </a:solidFill>
-            <a:prstDash val="solid"/>
-          </a:ln>
-        </p:spPr>
-        <p:txBody>
-          <a:bodyPr/>
-          <a:lstStyle/>
-          <a:p>
-            <a:endParaRPr lang="de-DE"/>
-          </a:p>
-        </p:txBody>
-      </p:sp>
-      <p:pic>
-        <p:nvPicPr>
-          <p:cNvPr id="10" name="icon-FaFlagCheckered" descr="C:\Users\Thanam\AppData\Local\Temp\claude\c--Projekt-Trainings-azure-basics-training\a7a6b8eb-22f3-4b42-aecc-5af05d1502b1\scratchpad\folien\assets\icons\FaFlagCheckered.png"/>
-          <p:cNvPicPr>
-            <a:picLocks noChangeAspect="1"/>
-          </p:cNvPicPr>
-          <p:nvPr/>
-        </p:nvPicPr>
-        <p:blipFill>
-          <a:blip r:embed="rId5"/>
-          <a:stretch>
-            <a:fillRect/>
-          </a:stretch>
-        </p:blipFill>
-        <p:spPr>
-          <a:xfrm>
-            <a:off x="680314" y="4497934"/>
-            <a:ext cx="285293" cy="285293"/>
-          </a:xfrm>
-          <a:prstGeom prst="rect">
-            <a:avLst/>
-          </a:prstGeom>
-        </p:spPr>
-      </p:pic>
-      <p:sp>
-        <p:nvSpPr>
-          <p:cNvPr id="11" name="Text 6"/>
-          <p:cNvSpPr txBox="1"/>
-          <p:nvPr/>
-        </p:nvSpPr>
-        <p:spPr>
-          <a:xfrm>
-            <a:off x="1325880" y="4160520"/>
-            <a:ext cx="10317175" cy="960120"/>
-          </a:xfrm>
-          <a:prstGeom prst="rect">
-            <a:avLst/>
-          </a:prstGeom>
-          <a:noFill/>
-          <a:ln/>
-        </p:spPr>
-        <p:txBody>
-          <a:bodyPr wrap="square" lIns="0" tIns="0" rIns="0" bIns="0" rtlCol="0" anchor="ctr"/>
-          <a:lstStyle/>
-          <a:p>
-            <a:pPr marL="0" indent="0">
-              <a:buNone/>
-            </a:pPr>
-            <a:r>
-              <a:rPr lang="en-US" sz="1800" b="1" dirty="0">
-                <a:solidFill>
-                  <a:srgbClr val="27303A"/>
-                </a:solidFill>
-              </a:rPr>
-              <a:t>Deine Erwartung</a:t>
-            </a:r>
-            <a:endParaRPr lang="en-US" sz="1800" dirty="0"/>
-          </a:p>
-          <a:p>
-            <a:pPr marL="0" indent="0">
-              <a:buNone/>
-            </a:pPr>
-            <a:r>
-              <a:rPr lang="en-US" sz="1800" dirty="0">
-                <a:solidFill>
-                  <a:srgbClr val="6F6F6F"/>
-                </a:solidFill>
-              </a:rPr>
-              <a:t>Was möchtest du nach dem Kurs </a:t>
-            </a:r>
-            <a:r>
-              <a:rPr lang="en-US" sz="1800" dirty="0" err="1">
-                <a:solidFill>
-                  <a:srgbClr val="6F6F6F"/>
-                </a:solidFill>
-              </a:rPr>
-              <a:t>können</a:t>
-            </a:r>
-            <a:r>
-              <a:rPr lang="en-US" sz="1800" dirty="0">
-                <a:solidFill>
-                  <a:srgbClr val="6F6F6F"/>
-                </a:solidFill>
-              </a:rPr>
-              <a:t>?</a:t>
-            </a:r>
-          </a:p>
-          <a:p>
-            <a:pPr marL="0" indent="0">
-              <a:buNone/>
-            </a:pPr>
-            <a:r>
-              <a:rPr lang="en-US" dirty="0">
-                <a:solidFill>
-                  <a:srgbClr val="6F6F6F"/>
-                </a:solidFill>
-              </a:rPr>
-              <a:t>-&gt; Menti </a:t>
-            </a:r>
-            <a:r>
-              <a:rPr lang="en-US" dirty="0" err="1">
-                <a:solidFill>
-                  <a:srgbClr val="6F6F6F"/>
-                </a:solidFill>
-              </a:rPr>
-              <a:t>Umfrage</a:t>
-            </a:r>
-            <a:endParaRPr lang="en-US" sz="1800" dirty="0">
-              <a:solidFill>
-                <a:srgbClr val="6F6F6F"/>
-              </a:solidFill>
-            </a:endParaRPr>
-          </a:p>
-        </p:txBody>
-      </p:sp>
-      <p:sp>
-        <p:nvSpPr>
           <p:cNvPr id="25" name="Slide Number Placeholder 0"/>
           <p:cNvSpPr>
             <a:spLocks noGrp="1"/>
@@ -4056,7 +4689,7 @@
           </a:prstGeom>
           <a:extLst>
             <a:ext uri="{C572A759-6A51-4108-AA02-DFA0A04FC94B}">
-              <ma14:wrappingTextBoxFlag xmlns:ma14="http://schemas.microsoft.com/office/mac/drawingml/2011/main" xmlns="" val="0"/>
+              <ma14:wrappingTextBoxFlag xmlns="" xmlns:ma14="http://schemas.microsoft.com/office/mac/drawingml/2011/main" val="0"/>
             </a:ext>
           </a:extLst>
         </p:spPr>
@@ -4159,7 +4792,7 @@
               <a:buNone/>
             </a:pPr>
             <a:r>
-              <a:rPr lang="de-DE" sz="1600" dirty="0">
+              <a:rPr lang="de-DE" sz="2000" dirty="0">
                 <a:solidFill>
                   <a:srgbClr val="27303A"/>
                 </a:solidFill>
@@ -4451,7 +5084,7 @@
         </p:nvSpPr>
         <p:spPr>
           <a:xfrm>
-            <a:off x="723900" y="4724400"/>
+            <a:off x="7150100" y="4724400"/>
             <a:ext cx="4318000" cy="1270000"/>
           </a:xfrm>
           <a:prstGeom prst="roundRect">
@@ -4482,7 +5115,7 @@
         </p:nvSpPr>
         <p:spPr>
           <a:xfrm>
-            <a:off x="927100" y="5080000"/>
+            <a:off x="7353300" y="5080000"/>
             <a:ext cx="558800" cy="558800"/>
           </a:xfrm>
           <a:prstGeom prst="ellipse">
@@ -4521,7 +5154,7 @@
         </p:nvSpPr>
         <p:spPr>
           <a:xfrm>
-            <a:off x="1689100" y="4876800"/>
+            <a:off x="8115300" y="4876800"/>
             <a:ext cx="3149600" cy="965200"/>
           </a:xfrm>
           <a:prstGeom prst="rect">
@@ -4572,7 +5205,7 @@
         </p:nvSpPr>
         <p:spPr>
           <a:xfrm>
-            <a:off x="7150100" y="4724400"/>
+            <a:off x="723900" y="4724400"/>
             <a:ext cx="4318000" cy="1270000"/>
           </a:xfrm>
           <a:prstGeom prst="roundRect">
@@ -4603,7 +5236,7 @@
         </p:nvSpPr>
         <p:spPr>
           <a:xfrm>
-            <a:off x="7353300" y="5080000"/>
+            <a:off x="927100" y="5080000"/>
             <a:ext cx="558800" cy="558800"/>
           </a:xfrm>
           <a:prstGeom prst="ellipse">
@@ -4642,7 +5275,7 @@
         </p:nvSpPr>
         <p:spPr>
           <a:xfrm>
-            <a:off x="8115300" y="4876800"/>
+            <a:off x="1689100" y="4876800"/>
             <a:ext cx="3149600" cy="965200"/>
           </a:xfrm>
           <a:prstGeom prst="rect">
@@ -4891,14 +5524,153 @@
         </p:blipFill>
         <p:spPr>
           <a:xfrm>
-            <a:off x="4410170" y="1743323"/>
-            <a:ext cx="3371353" cy="3371353"/>
+            <a:off x="7322047" y="2171352"/>
+            <a:ext cx="2515296" cy="2515296"/>
           </a:xfrm>
           <a:prstGeom prst="rect">
             <a:avLst/>
           </a:prstGeom>
         </p:spPr>
       </p:pic>
+      <p:sp>
+        <p:nvSpPr>
+          <p:cNvPr id="5" name="icon-kreis-FaFlagCheckered">
+            <a:extLst>
+              <a:ext uri="{FF2B5EF4-FFF2-40B4-BE49-F238E27FC236}">
+                <a16:creationId xmlns:a16="http://schemas.microsoft.com/office/drawing/2014/main" id="{1A1B2B5C-8CF3-0103-96FB-918FF346A788}"/>
+              </a:ext>
+            </a:extLst>
+          </p:cNvPr>
+          <p:cNvSpPr/>
+          <p:nvPr/>
+        </p:nvSpPr>
+        <p:spPr>
+          <a:xfrm>
+            <a:off x="1228954" y="3061243"/>
+            <a:ext cx="548640" cy="548640"/>
+          </a:xfrm>
+          <a:prstGeom prst="ellipse">
+            <a:avLst/>
+          </a:prstGeom>
+          <a:solidFill>
+            <a:srgbClr val="006FAD"/>
+          </a:solidFill>
+          <a:ln w="12700">
+            <a:solidFill>
+              <a:srgbClr val="006FAD"/>
+            </a:solidFill>
+            <a:prstDash val="solid"/>
+          </a:ln>
+        </p:spPr>
+        <p:txBody>
+          <a:bodyPr/>
+          <a:lstStyle/>
+          <a:p>
+            <a:endParaRPr lang="de-DE"/>
+          </a:p>
+        </p:txBody>
+      </p:sp>
+      <p:pic>
+        <p:nvPicPr>
+          <p:cNvPr id="7" name="icon-FaFlagCheckered" descr="C:\Users\Thanam\AppData\Local\Temp\claude\c--Projekt-Trainings-azure-basics-training\a7a6b8eb-22f3-4b42-aecc-5af05d1502b1\scratchpad\folien\assets\icons\FaFlagCheckered.png">
+            <a:extLst>
+              <a:ext uri="{FF2B5EF4-FFF2-40B4-BE49-F238E27FC236}">
+                <a16:creationId xmlns:a16="http://schemas.microsoft.com/office/drawing/2014/main" id="{0A55C237-7BE3-DBE5-5EB1-4628D5F59626}"/>
+              </a:ext>
+            </a:extLst>
+          </p:cNvPr>
+          <p:cNvPicPr>
+            <a:picLocks noChangeAspect="1"/>
+          </p:cNvPicPr>
+          <p:nvPr/>
+        </p:nvPicPr>
+        <p:blipFill>
+          <a:blip r:embed="rId3"/>
+          <a:stretch>
+            <a:fillRect/>
+          </a:stretch>
+        </p:blipFill>
+        <p:spPr>
+          <a:xfrm>
+            <a:off x="1360628" y="3192917"/>
+            <a:ext cx="285293" cy="285293"/>
+          </a:xfrm>
+          <a:prstGeom prst="rect">
+            <a:avLst/>
+          </a:prstGeom>
+        </p:spPr>
+      </p:pic>
+      <p:sp>
+        <p:nvSpPr>
+          <p:cNvPr id="9" name="Text 6">
+            <a:extLst>
+              <a:ext uri="{FF2B5EF4-FFF2-40B4-BE49-F238E27FC236}">
+                <a16:creationId xmlns:a16="http://schemas.microsoft.com/office/drawing/2014/main" id="{EB5916DE-70F6-16D2-3737-F2182D66E857}"/>
+              </a:ext>
+            </a:extLst>
+          </p:cNvPr>
+          <p:cNvSpPr txBox="1"/>
+          <p:nvPr/>
+        </p:nvSpPr>
+        <p:spPr>
+          <a:xfrm>
+            <a:off x="2006194" y="2948940"/>
+            <a:ext cx="10317175" cy="960120"/>
+          </a:xfrm>
+          <a:prstGeom prst="rect">
+            <a:avLst/>
+          </a:prstGeom>
+          <a:noFill/>
+          <a:ln/>
+        </p:spPr>
+        <p:txBody>
+          <a:bodyPr wrap="square" lIns="0" tIns="0" rIns="0" bIns="0" rtlCol="0" anchor="ctr"/>
+          <a:lstStyle/>
+          <a:p>
+            <a:pPr marL="0" indent="0">
+              <a:buNone/>
+            </a:pPr>
+            <a:r>
+              <a:rPr lang="en-US" sz="1800" b="1" dirty="0">
+                <a:solidFill>
+                  <a:srgbClr val="27303A"/>
+                </a:solidFill>
+              </a:rPr>
+              <a:t>Deine Erwartung</a:t>
+            </a:r>
+            <a:endParaRPr lang="en-US" sz="1800" dirty="0"/>
+          </a:p>
+          <a:p>
+            <a:pPr marL="0" indent="0">
+              <a:buNone/>
+            </a:pPr>
+            <a:r>
+              <a:rPr lang="en-US" sz="1800" dirty="0">
+                <a:solidFill>
+                  <a:srgbClr val="6F6F6F"/>
+                </a:solidFill>
+              </a:rPr>
+              <a:t>Was möchtest du nach dem Kurs </a:t>
+            </a:r>
+            <a:r>
+              <a:rPr lang="en-US" sz="1800" dirty="0" err="1">
+                <a:solidFill>
+                  <a:srgbClr val="6F6F6F"/>
+                </a:solidFill>
+              </a:rPr>
+              <a:t>können</a:t>
+            </a:r>
+            <a:r>
+              <a:rPr lang="en-US" sz="1800" dirty="0">
+                <a:solidFill>
+                  <a:srgbClr val="6F6F6F"/>
+                </a:solidFill>
+              </a:rPr>
+              <a:t>?</a:t>
+            </a:r>
+          </a:p>
+        </p:txBody>
+      </p:sp>
     </p:spTree>
     <p:extLst>
       <p:ext uri="{BB962C8B-B14F-4D97-AF65-F5344CB8AC3E}">
@@ -4913,6 +5685,107 @@
 </file>
 
 <file path=ppt/slides/slide5.xml><?xml version="1.0" encoding="utf-8"?>
+<p:sld xmlns:a="http://schemas.openxmlformats.org/drawingml/2006/main" xmlns:r="http://schemas.openxmlformats.org/officeDocument/2006/relationships" xmlns:p="http://schemas.openxmlformats.org/presentationml/2006/main">
+  <p:cSld>
+    <p:spTree>
+      <p:nvGrpSpPr>
+        <p:cNvPr id="1" name=""/>
+        <p:cNvGrpSpPr/>
+        <p:nvPr/>
+      </p:nvGrpSpPr>
+      <p:grpSpPr>
+        <a:xfrm>
+          <a:off x="0" y="0"/>
+          <a:ext cx="0" cy="0"/>
+          <a:chOff x="0" y="0"/>
+          <a:chExt cx="0" cy="0"/>
+        </a:xfrm>
+      </p:grpSpPr>
+      <p:sp>
+        <p:nvSpPr>
+          <p:cNvPr id="2" name="Title 1">
+            <a:extLst>
+              <a:ext uri="{FF2B5EF4-FFF2-40B4-BE49-F238E27FC236}">
+                <a16:creationId xmlns:a16="http://schemas.microsoft.com/office/drawing/2014/main" id="{01BC64D0-BDBE-465B-36A6-4921E8694E30}"/>
+              </a:ext>
+            </a:extLst>
+          </p:cNvPr>
+          <p:cNvSpPr>
+            <a:spLocks noGrp="1"/>
+          </p:cNvSpPr>
+          <p:nvPr>
+            <p:ph type="title" idx="102"/>
+          </p:nvPr>
+        </p:nvSpPr>
+        <p:spPr/>
+        <p:txBody>
+          <a:bodyPr/>
+          <a:lstStyle/>
+          <a:p>
+            <a:r>
+              <a:rPr lang="de-CH" dirty="0"/>
+              <a:t>Kurs-Trainer stellt sich vor</a:t>
+            </a:r>
+            <a:endParaRPr lang="de-DE" dirty="0"/>
+          </a:p>
+        </p:txBody>
+      </p:sp>
+      <p:sp>
+        <p:nvSpPr>
+          <p:cNvPr id="4" name="Text 1">
+            <a:extLst>
+              <a:ext uri="{FF2B5EF4-FFF2-40B4-BE49-F238E27FC236}">
+                <a16:creationId xmlns:a16="http://schemas.microsoft.com/office/drawing/2014/main" id="{D68F0A13-A527-6FBC-9F95-26FEA5633672}"/>
+              </a:ext>
+            </a:extLst>
+          </p:cNvPr>
+          <p:cNvSpPr txBox="1"/>
+          <p:nvPr/>
+        </p:nvSpPr>
+        <p:spPr>
+          <a:xfrm>
+            <a:off x="2660883" y="3200400"/>
+            <a:ext cx="6869927" cy="457200"/>
+          </a:xfrm>
+          <a:prstGeom prst="rect">
+            <a:avLst/>
+          </a:prstGeom>
+          <a:noFill/>
+          <a:ln/>
+        </p:spPr>
+        <p:txBody>
+          <a:bodyPr wrap="square" lIns="0" tIns="0" rIns="0" bIns="0" rtlCol="0" anchor="ctr"/>
+          <a:lstStyle/>
+          <a:p>
+            <a:pPr marL="0" indent="0">
+              <a:buNone/>
+            </a:pPr>
+            <a:r>
+              <a:rPr lang="en-US" sz="8000" b="1" dirty="0">
+                <a:solidFill>
+                  <a:srgbClr val="006FAD"/>
+                </a:solidFill>
+              </a:rPr>
+              <a:t>Thanam Pangri</a:t>
+            </a:r>
+            <a:endParaRPr lang="en-US" sz="8000" dirty="0"/>
+          </a:p>
+        </p:txBody>
+      </p:sp>
+    </p:spTree>
+    <p:extLst>
+      <p:ext uri="{BB962C8B-B14F-4D97-AF65-F5344CB8AC3E}">
+        <p14:creationId xmlns:p14="http://schemas.microsoft.com/office/powerpoint/2010/main" val="3417921297"/>
+      </p:ext>
+    </p:extLst>
+  </p:cSld>
+  <p:clrMapOvr>
+    <a:masterClrMapping/>
+  </p:clrMapOvr>
+</p:sld>
+</file>
+
+<file path=ppt/slides/slide6.xml><?xml version="1.0" encoding="utf-8"?>
 <p:sld xmlns:a="http://schemas.openxmlformats.org/drawingml/2006/main" xmlns:r="http://schemas.openxmlformats.org/officeDocument/2006/relationships" xmlns:p="http://schemas.openxmlformats.org/presentationml/2006/main">
   <p:cSld name="Slide 3">
     <p:spTree>
@@ -5191,7 +6064,7 @@
           </a:prstGeom>
           <a:extLst>
             <a:ext uri="{C572A759-6A51-4108-AA02-DFA0A04FC94B}">
-              <ma14:wrappingTextBoxFlag xmlns:ma14="http://schemas.microsoft.com/office/mac/drawingml/2011/main" xmlns="" val="0"/>
+              <ma14:wrappingTextBoxFlag xmlns="" xmlns:ma14="http://schemas.microsoft.com/office/mac/drawingml/2011/main" val="0"/>
             </a:ext>
           </a:extLst>
         </p:spPr>
@@ -5210,7 +6083,7 @@
             <a:pPr algn="r"/>
             <a:fld id="{F7021451-1387-4CA6-816F-3879F97B5CBC}" type="slidenum">
               <a:rPr lang="en-US" b="0"/>
-              <a:t>5</a:t>
+              <a:t>6</a:t>
             </a:fld>
             <a:endParaRPr lang="en-US"/>
           </a:p>
@@ -5224,7 +6097,7 @@
 </p:sld>
 </file>
 
-<file path=ppt/slides/slide6.xml><?xml version="1.0" encoding="utf-8"?>
+<file path=ppt/slides/slide7.xml><?xml version="1.0" encoding="utf-8"?>
 <p:sld xmlns:a="http://schemas.openxmlformats.org/drawingml/2006/main" xmlns:r="http://schemas.openxmlformats.org/officeDocument/2006/relationships" xmlns:p="http://schemas.openxmlformats.org/presentationml/2006/main">
   <p:cSld name="Slide 4">
     <p:spTree>
@@ -6136,7 +7009,7 @@
           </a:prstGeom>
           <a:extLst>
             <a:ext uri="{C572A759-6A51-4108-AA02-DFA0A04FC94B}">
-              <ma14:wrappingTextBoxFlag xmlns:ma14="http://schemas.microsoft.com/office/mac/drawingml/2011/main" xmlns="" val="0"/>
+              <ma14:wrappingTextBoxFlag xmlns="" xmlns:ma14="http://schemas.microsoft.com/office/mac/drawingml/2011/main" val="0"/>
             </a:ext>
           </a:extLst>
         </p:spPr>
@@ -6155,7 +7028,7 @@
             <a:pPr algn="r"/>
             <a:fld id="{F7021451-1387-4CA6-816F-3879F97B5CBC}" type="slidenum">
               <a:rPr lang="en-US" b="0"/>
-              <a:t>6</a:t>
+              <a:t>7</a:t>
             </a:fld>
             <a:endParaRPr lang="en-US"/>
           </a:p>
@@ -6169,7 +7042,7 @@
 </p:sld>
 </file>
 
-<file path=ppt/slides/slide7.xml><?xml version="1.0" encoding="utf-8"?>
+<file path=ppt/slides/slide8.xml><?xml version="1.0" encoding="utf-8"?>
 <p:sld xmlns:a="http://schemas.openxmlformats.org/drawingml/2006/main" xmlns:r="http://schemas.openxmlformats.org/officeDocument/2006/relationships" xmlns:p="http://schemas.openxmlformats.org/presentationml/2006/main">
   <p:cSld name="Slide 5">
     <p:spTree>
@@ -7471,7 +8344,7 @@
           </a:prstGeom>
           <a:extLst>
             <a:ext uri="{C572A759-6A51-4108-AA02-DFA0A04FC94B}">
-              <ma14:wrappingTextBoxFlag xmlns:ma14="http://schemas.microsoft.com/office/mac/drawingml/2011/main" xmlns="" val="0"/>
+              <ma14:wrappingTextBoxFlag xmlns="" xmlns:ma14="http://schemas.microsoft.com/office/mac/drawingml/2011/main" val="0"/>
             </a:ext>
           </a:extLst>
         </p:spPr>
@@ -7490,7 +8363,7 @@
             <a:pPr algn="r"/>
             <a:fld id="{F7021451-1387-4CA6-816F-3879F97B5CBC}" type="slidenum">
               <a:rPr lang="en-US" b="0"/>
-              <a:t>7</a:t>
+              <a:t>8</a:t>
             </a:fld>
             <a:endParaRPr lang="en-US"/>
           </a:p>
@@ -7504,7 +8377,7 @@
 </p:sld>
 </file>
 
-<file path=ppt/slides/slide8.xml><?xml version="1.0" encoding="utf-8"?>
+<file path=ppt/slides/slide9.xml><?xml version="1.0" encoding="utf-8"?>
 <p:sld xmlns:a="http://schemas.openxmlformats.org/drawingml/2006/main" xmlns:r="http://schemas.openxmlformats.org/officeDocument/2006/relationships" xmlns:p="http://schemas.openxmlformats.org/presentationml/2006/main">
   <p:cSld name="Slide 6">
     <p:spTree>
@@ -8487,785 +9360,7 @@
           </a:prstGeom>
           <a:extLst>
             <a:ext uri="{C572A759-6A51-4108-AA02-DFA0A04FC94B}">
-              <ma14:wrappingTextBoxFlag xmlns:ma14="http://schemas.microsoft.com/office/mac/drawingml/2011/main" xmlns="" val="0"/>
-            </a:ext>
-          </a:extLst>
-        </p:spPr>
-        <p:txBody>
-          <a:bodyPr/>
-          <a:lstStyle>
-            <a:lvl1pPr>
-              <a:defRPr sz="1000">
-                <a:solidFill>
-                  <a:srgbClr val="6F6F6F"/>
-                </a:solidFill>
-              </a:defRPr>
-            </a:lvl1pPr>
-          </a:lstStyle>
-          <a:p>
-            <a:pPr algn="r"/>
-            <a:fld id="{F7021451-1387-4CA6-816F-3879F97B5CBC}" type="slidenum">
-              <a:rPr lang="en-US" b="0"/>
-              <a:t>8</a:t>
-            </a:fld>
-            <a:endParaRPr lang="en-US"/>
-          </a:p>
-        </p:txBody>
-      </p:sp>
-    </p:spTree>
-  </p:cSld>
-  <p:clrMapOvr>
-    <a:masterClrMapping/>
-  </p:clrMapOvr>
-</p:sld>
-</file>
-
-<file path=ppt/slides/slide9.xml><?xml version="1.0" encoding="utf-8"?>
-<p:sld xmlns:a="http://schemas.openxmlformats.org/drawingml/2006/main" xmlns:r="http://schemas.openxmlformats.org/officeDocument/2006/relationships" xmlns:p="http://schemas.openxmlformats.org/presentationml/2006/main">
-  <p:cSld name="Slide 7">
-    <p:spTree>
-      <p:nvGrpSpPr>
-        <p:cNvPr id="1" name=""/>
-        <p:cNvGrpSpPr/>
-        <p:nvPr/>
-      </p:nvGrpSpPr>
-      <p:grpSpPr>
-        <a:xfrm>
-          <a:off x="0" y="0"/>
-          <a:ext cx="0" cy="0"/>
-          <a:chOff x="0" y="0"/>
-          <a:chExt cx="0" cy="0"/>
-        </a:xfrm>
-      </p:grpSpPr>
-      <p:sp>
-        <p:nvSpPr>
-          <p:cNvPr id="2" name="Text 1"/>
-          <p:cNvSpPr>
-            <a:spLocks noGrp="1"/>
-          </p:cNvSpPr>
-          <p:nvPr>
-            <p:ph type="title" idx="102" hasCustomPrompt="1"/>
-          </p:nvPr>
-        </p:nvSpPr>
-        <p:spPr>
-          <a:xfrm>
-            <a:off x="548640" y="320040"/>
-            <a:ext cx="11094415" cy="822960"/>
-          </a:xfrm>
-          <a:prstGeom prst="rect">
-            <a:avLst/>
-          </a:prstGeom>
-          <a:noFill/>
-          <a:ln/>
-        </p:spPr>
-        <p:txBody>
-          <a:bodyPr wrap="square" lIns="0" tIns="0" rIns="0" bIns="0" rtlCol="0" anchor="ctr"/>
-          <a:lstStyle/>
-          <a:p>
-            <a:pPr marL="0" indent="0" algn="l">
-              <a:buNone/>
-            </a:pPr>
-            <a:r>
-              <a:rPr lang="en-US" sz="3400" b="1" dirty="0">
-                <a:solidFill>
-                  <a:srgbClr val="27303A"/>
-                </a:solidFill>
-              </a:rPr>
-              <a:t>So arbeiten wir</a:t>
-            </a:r>
-            <a:endParaRPr lang="en-US" sz="3400" dirty="0"/>
-          </a:p>
-        </p:txBody>
-      </p:sp>
-      <p:sp>
-        <p:nvSpPr>
-          <p:cNvPr id="3" name="karte"/>
-          <p:cNvSpPr/>
-          <p:nvPr/>
-        </p:nvSpPr>
-        <p:spPr>
-          <a:xfrm>
-            <a:off x="548640" y="1325880"/>
-            <a:ext cx="5410048" cy="2217420"/>
-          </a:xfrm>
-          <a:prstGeom prst="roundRect">
-            <a:avLst>
-              <a:gd name="adj" fmla="val 4948"/>
-            </a:avLst>
-          </a:prstGeom>
-          <a:solidFill>
-            <a:srgbClr val="F7F7F7"/>
-          </a:solidFill>
-          <a:ln w="12700">
-            <a:solidFill>
-              <a:srgbClr val="F7F7F7"/>
-            </a:solidFill>
-            <a:prstDash val="solid"/>
-          </a:ln>
-        </p:spPr>
-        <p:txBody>
-          <a:bodyPr/>
-          <a:lstStyle/>
-          <a:p>
-            <a:endParaRPr lang="de-DE"/>
-          </a:p>
-        </p:txBody>
-      </p:sp>
-      <p:sp>
-        <p:nvSpPr>
-          <p:cNvPr id="4" name="icon-kreis-FaPencilAlt"/>
-          <p:cNvSpPr/>
-          <p:nvPr/>
-        </p:nvSpPr>
-        <p:spPr>
-          <a:xfrm>
-            <a:off x="822960" y="1600200"/>
-            <a:ext cx="640080" cy="640080"/>
-          </a:xfrm>
-          <a:prstGeom prst="ellipse">
-            <a:avLst/>
-          </a:prstGeom>
-          <a:solidFill>
-            <a:srgbClr val="006FAD"/>
-          </a:solidFill>
-          <a:ln w="12700">
-            <a:solidFill>
-              <a:srgbClr val="006FAD"/>
-            </a:solidFill>
-            <a:prstDash val="solid"/>
-          </a:ln>
-        </p:spPr>
-        <p:txBody>
-          <a:bodyPr/>
-          <a:lstStyle/>
-          <a:p>
-            <a:endParaRPr lang="de-DE"/>
-          </a:p>
-        </p:txBody>
-      </p:sp>
-      <p:pic>
-        <p:nvPicPr>
-          <p:cNvPr id="5" name="icon-FaPencilAlt" descr="C:\Users\Thanam\AppData\Local\Temp\claude\c--Projekt-Trainings-azure-basics-training\a7a6b8eb-22f3-4b42-aecc-5af05d1502b1\scratchpad\folien\assets\icons\FaPencilAlt.png"/>
-          <p:cNvPicPr>
-            <a:picLocks noChangeAspect="1"/>
-          </p:cNvPicPr>
-          <p:nvPr/>
-        </p:nvPicPr>
-        <p:blipFill>
-          <a:blip r:embed="rId3"/>
-          <a:stretch>
-            <a:fillRect/>
-          </a:stretch>
-        </p:blipFill>
-        <p:spPr>
-          <a:xfrm>
-            <a:off x="976579" y="1753819"/>
-            <a:ext cx="332842" cy="332842"/>
-          </a:xfrm>
-          <a:prstGeom prst="rect">
-            <a:avLst/>
-          </a:prstGeom>
-        </p:spPr>
-      </p:pic>
-      <p:sp>
-        <p:nvSpPr>
-          <p:cNvPr id="6" name="Text 3"/>
-          <p:cNvSpPr txBox="1"/>
-          <p:nvPr/>
-        </p:nvSpPr>
-        <p:spPr>
-          <a:xfrm>
-            <a:off x="1645920" y="1600200"/>
-            <a:ext cx="4084168" cy="640080"/>
-          </a:xfrm>
-          <a:prstGeom prst="rect">
-            <a:avLst/>
-          </a:prstGeom>
-          <a:noFill/>
-          <a:ln/>
-        </p:spPr>
-        <p:txBody>
-          <a:bodyPr wrap="square" lIns="0" tIns="0" rIns="0" bIns="0" rtlCol="0" anchor="ctr">
-            <a:normAutofit/>
-          </a:bodyPr>
-          <a:lstStyle/>
-          <a:p>
-            <a:pPr marL="0" indent="0">
-              <a:buNone/>
-            </a:pPr>
-            <a:r>
-              <a:rPr lang="en-US" sz="2000" b="1" dirty="0">
-                <a:solidFill>
-                  <a:srgbClr val="27303A"/>
-                </a:solidFill>
-              </a:rPr>
-              <a:t>Lernjournal</a:t>
-            </a:r>
-            <a:endParaRPr lang="en-US" sz="2000" dirty="0"/>
-          </a:p>
-        </p:txBody>
-      </p:sp>
-      <p:sp>
-        <p:nvSpPr>
-          <p:cNvPr id="7" name="Text 4"/>
-          <p:cNvSpPr txBox="1"/>
-          <p:nvPr/>
-        </p:nvSpPr>
-        <p:spPr>
-          <a:xfrm>
-            <a:off x="822960" y="2423160"/>
-            <a:ext cx="4861408" cy="982980"/>
-          </a:xfrm>
-          <a:prstGeom prst="rect">
-            <a:avLst/>
-          </a:prstGeom>
-          <a:noFill/>
-          <a:ln/>
-        </p:spPr>
-        <p:txBody>
-          <a:bodyPr wrap="square" lIns="0" tIns="0" rIns="0" bIns="0" rtlCol="0" anchor="t"/>
-          <a:lstStyle/>
-          <a:p>
-            <a:pPr marL="0" indent="0">
-              <a:spcAft>
-                <a:spcPts val="400"/>
-              </a:spcAft>
-              <a:buNone/>
-            </a:pPr>
-            <a:r>
-              <a:rPr lang="en-US" sz="1600" dirty="0">
-                <a:solidFill>
-                  <a:srgbClr val="27303A"/>
-                </a:solidFill>
-              </a:rPr>
-              <a:t>Pro Auftrag: Befehle, Screenshot als Nachweis (ohne persönliche Daten), was nicht geklappt hat.</a:t>
-            </a:r>
-            <a:endParaRPr lang="en-US" sz="1600" dirty="0"/>
-          </a:p>
-        </p:txBody>
-      </p:sp>
-      <p:sp>
-        <p:nvSpPr>
-          <p:cNvPr id="8" name="karte"/>
-          <p:cNvSpPr/>
-          <p:nvPr/>
-        </p:nvSpPr>
-        <p:spPr>
-          <a:xfrm>
-            <a:off x="6233008" y="1325880"/>
-            <a:ext cx="5410048" cy="2217420"/>
-          </a:xfrm>
-          <a:prstGeom prst="roundRect">
-            <a:avLst>
-              <a:gd name="adj" fmla="val 4948"/>
-            </a:avLst>
-          </a:prstGeom>
-          <a:solidFill>
-            <a:srgbClr val="F7F7F7"/>
-          </a:solidFill>
-          <a:ln w="12700">
-            <a:solidFill>
-              <a:srgbClr val="F7F7F7"/>
-            </a:solidFill>
-            <a:prstDash val="solid"/>
-          </a:ln>
-        </p:spPr>
-        <p:txBody>
-          <a:bodyPr/>
-          <a:lstStyle/>
-          <a:p>
-            <a:endParaRPr lang="de-DE"/>
-          </a:p>
-        </p:txBody>
-      </p:sp>
-      <p:sp>
-        <p:nvSpPr>
-          <p:cNvPr id="9" name="icon-kreis-FaUsers"/>
-          <p:cNvSpPr/>
-          <p:nvPr/>
-        </p:nvSpPr>
-        <p:spPr>
-          <a:xfrm>
-            <a:off x="6507328" y="1600200"/>
-            <a:ext cx="640080" cy="640080"/>
-          </a:xfrm>
-          <a:prstGeom prst="ellipse">
-            <a:avLst/>
-          </a:prstGeom>
-          <a:solidFill>
-            <a:srgbClr val="006FAD"/>
-          </a:solidFill>
-          <a:ln w="12700">
-            <a:solidFill>
-              <a:srgbClr val="006FAD"/>
-            </a:solidFill>
-            <a:prstDash val="solid"/>
-          </a:ln>
-        </p:spPr>
-        <p:txBody>
-          <a:bodyPr/>
-          <a:lstStyle/>
-          <a:p>
-            <a:endParaRPr lang="de-DE"/>
-          </a:p>
-        </p:txBody>
-      </p:sp>
-      <p:pic>
-        <p:nvPicPr>
-          <p:cNvPr id="10" name="icon-FaUsers" descr="C:\Users\Thanam\AppData\Local\Temp\claude\c--Projekt-Trainings-azure-basics-training\a7a6b8eb-22f3-4b42-aecc-5af05d1502b1\scratchpad\folien\assets\icons\FaUsers.png"/>
-          <p:cNvPicPr>
-            <a:picLocks noChangeAspect="1"/>
-          </p:cNvPicPr>
-          <p:nvPr/>
-        </p:nvPicPr>
-        <p:blipFill>
-          <a:blip r:embed="rId4"/>
-          <a:stretch>
-            <a:fillRect/>
-          </a:stretch>
-        </p:blipFill>
-        <p:spPr>
-          <a:xfrm>
-            <a:off x="6660947" y="1753819"/>
-            <a:ext cx="332842" cy="332842"/>
-          </a:xfrm>
-          <a:prstGeom prst="rect">
-            <a:avLst/>
-          </a:prstGeom>
-        </p:spPr>
-      </p:pic>
-      <p:sp>
-        <p:nvSpPr>
-          <p:cNvPr id="11" name="Text 7"/>
-          <p:cNvSpPr txBox="1"/>
-          <p:nvPr/>
-        </p:nvSpPr>
-        <p:spPr>
-          <a:xfrm>
-            <a:off x="7330288" y="1600200"/>
-            <a:ext cx="4084168" cy="640080"/>
-          </a:xfrm>
-          <a:prstGeom prst="rect">
-            <a:avLst/>
-          </a:prstGeom>
-          <a:noFill/>
-          <a:ln/>
-        </p:spPr>
-        <p:txBody>
-          <a:bodyPr wrap="square" lIns="0" tIns="0" rIns="0" bIns="0" rtlCol="0" anchor="ctr">
-            <a:normAutofit/>
-          </a:bodyPr>
-          <a:lstStyle/>
-          <a:p>
-            <a:pPr marL="0" indent="0">
-              <a:buNone/>
-            </a:pPr>
-            <a:r>
-              <a:rPr lang="en-US" sz="2000" b="1" dirty="0">
-                <a:solidFill>
-                  <a:srgbClr val="27303A"/>
-                </a:solidFill>
-              </a:rPr>
-              <a:t>Partnerarbeit</a:t>
-            </a:r>
-            <a:endParaRPr lang="en-US" sz="2000" dirty="0"/>
-          </a:p>
-        </p:txBody>
-      </p:sp>
-      <p:sp>
-        <p:nvSpPr>
-          <p:cNvPr id="12" name="Text 8"/>
-          <p:cNvSpPr txBox="1"/>
-          <p:nvPr/>
-        </p:nvSpPr>
-        <p:spPr>
-          <a:xfrm>
-            <a:off x="6507328" y="2423160"/>
-            <a:ext cx="4861408" cy="982980"/>
-          </a:xfrm>
-          <a:prstGeom prst="rect">
-            <a:avLst/>
-          </a:prstGeom>
-          <a:noFill/>
-          <a:ln/>
-        </p:spPr>
-        <p:txBody>
-          <a:bodyPr wrap="square" lIns="0" tIns="0" rIns="0" bIns="0" rtlCol="0" anchor="t"/>
-          <a:lstStyle/>
-          <a:p>
-            <a:pPr marL="0" indent="0">
-              <a:spcAft>
-                <a:spcPts val="400"/>
-              </a:spcAft>
-              <a:buNone/>
-            </a:pPr>
-            <a:r>
-              <a:rPr lang="en-US" sz="1600" dirty="0">
-                <a:solidFill>
-                  <a:srgbClr val="27303A"/>
-                </a:solidFill>
-              </a:rPr>
-              <a:t>Driver tippt, Navigator liest und kontrolliert. Nach jedem Auftrag wechseln.</a:t>
-            </a:r>
-            <a:endParaRPr lang="en-US" sz="1600" dirty="0"/>
-          </a:p>
-        </p:txBody>
-      </p:sp>
-      <p:sp>
-        <p:nvSpPr>
-          <p:cNvPr id="13" name="karte"/>
-          <p:cNvSpPr/>
-          <p:nvPr/>
-        </p:nvSpPr>
-        <p:spPr>
-          <a:xfrm>
-            <a:off x="548640" y="3817620"/>
-            <a:ext cx="5410048" cy="2217420"/>
-          </a:xfrm>
-          <a:prstGeom prst="roundRect">
-            <a:avLst>
-              <a:gd name="adj" fmla="val 4948"/>
-            </a:avLst>
-          </a:prstGeom>
-          <a:solidFill>
-            <a:srgbClr val="F7F7F7"/>
-          </a:solidFill>
-          <a:ln w="12700">
-            <a:solidFill>
-              <a:srgbClr val="F7F7F7"/>
-            </a:solidFill>
-            <a:prstDash val="solid"/>
-          </a:ln>
-        </p:spPr>
-        <p:txBody>
-          <a:bodyPr/>
-          <a:lstStyle/>
-          <a:p>
-            <a:endParaRPr lang="de-DE"/>
-          </a:p>
-        </p:txBody>
-      </p:sp>
-      <p:sp>
-        <p:nvSpPr>
-          <p:cNvPr id="14" name="icon-kreis-FaClock"/>
-          <p:cNvSpPr/>
-          <p:nvPr/>
-        </p:nvSpPr>
-        <p:spPr>
-          <a:xfrm>
-            <a:off x="822960" y="4091940"/>
-            <a:ext cx="640080" cy="640080"/>
-          </a:xfrm>
-          <a:prstGeom prst="ellipse">
-            <a:avLst/>
-          </a:prstGeom>
-          <a:solidFill>
-            <a:srgbClr val="006FAD"/>
-          </a:solidFill>
-          <a:ln w="12700">
-            <a:solidFill>
-              <a:srgbClr val="006FAD"/>
-            </a:solidFill>
-            <a:prstDash val="solid"/>
-          </a:ln>
-        </p:spPr>
-        <p:txBody>
-          <a:bodyPr/>
-          <a:lstStyle/>
-          <a:p>
-            <a:endParaRPr lang="de-DE"/>
-          </a:p>
-        </p:txBody>
-      </p:sp>
-      <p:pic>
-        <p:nvPicPr>
-          <p:cNvPr id="15" name="icon-FaClock" descr="C:\Users\Thanam\AppData\Local\Temp\claude\c--Projekt-Trainings-azure-basics-training\a7a6b8eb-22f3-4b42-aecc-5af05d1502b1\scratchpad\folien\assets\icons\FaClock.png"/>
-          <p:cNvPicPr>
-            <a:picLocks noChangeAspect="1"/>
-          </p:cNvPicPr>
-          <p:nvPr/>
-        </p:nvPicPr>
-        <p:blipFill>
-          <a:blip r:embed="rId5"/>
-          <a:stretch>
-            <a:fillRect/>
-          </a:stretch>
-        </p:blipFill>
-        <p:spPr>
-          <a:xfrm>
-            <a:off x="976579" y="4245559"/>
-            <a:ext cx="332842" cy="332842"/>
-          </a:xfrm>
-          <a:prstGeom prst="rect">
-            <a:avLst/>
-          </a:prstGeom>
-        </p:spPr>
-      </p:pic>
-      <p:sp>
-        <p:nvSpPr>
-          <p:cNvPr id="16" name="Text 11"/>
-          <p:cNvSpPr txBox="1"/>
-          <p:nvPr/>
-        </p:nvSpPr>
-        <p:spPr>
-          <a:xfrm>
-            <a:off x="1645920" y="4091940"/>
-            <a:ext cx="4084168" cy="640080"/>
-          </a:xfrm>
-          <a:prstGeom prst="rect">
-            <a:avLst/>
-          </a:prstGeom>
-          <a:noFill/>
-          <a:ln/>
-        </p:spPr>
-        <p:txBody>
-          <a:bodyPr wrap="square" lIns="0" tIns="0" rIns="0" bIns="0" rtlCol="0" anchor="ctr">
-            <a:normAutofit/>
-          </a:bodyPr>
-          <a:lstStyle/>
-          <a:p>
-            <a:pPr marL="0" indent="0">
-              <a:buNone/>
-            </a:pPr>
-            <a:r>
-              <a:rPr lang="en-US" sz="2000" b="1" dirty="0">
-                <a:solidFill>
-                  <a:srgbClr val="27303A"/>
-                </a:solidFill>
-              </a:rPr>
-              <a:t>Hilfe holen</a:t>
-            </a:r>
-            <a:endParaRPr lang="en-US" sz="2000" dirty="0"/>
-          </a:p>
-        </p:txBody>
-      </p:sp>
-      <p:sp>
-        <p:nvSpPr>
-          <p:cNvPr id="17" name="Text 12"/>
-          <p:cNvSpPr txBox="1"/>
-          <p:nvPr/>
-        </p:nvSpPr>
-        <p:spPr>
-          <a:xfrm>
-            <a:off x="822960" y="4914900"/>
-            <a:ext cx="4861408" cy="982980"/>
-          </a:xfrm>
-          <a:prstGeom prst="rect">
-            <a:avLst/>
-          </a:prstGeom>
-          <a:noFill/>
-          <a:ln/>
-        </p:spPr>
-        <p:txBody>
-          <a:bodyPr wrap="square" lIns="0" tIns="0" rIns="0" bIns="0" rtlCol="0" anchor="t"/>
-          <a:lstStyle/>
-          <a:p>
-            <a:pPr marL="0" indent="0">
-              <a:spcAft>
-                <a:spcPts val="400"/>
-              </a:spcAft>
-              <a:buNone/>
-            </a:pPr>
-            <a:r>
-              <a:rPr lang="en-US" sz="1600" dirty="0">
-                <a:solidFill>
-                  <a:srgbClr val="27303A"/>
-                </a:solidFill>
-              </a:rPr>
-              <a:t>10 Minuten selbst probieren, dann Partner fragen, dann Kursleitung.</a:t>
-            </a:r>
-            <a:endParaRPr lang="en-US" sz="1600" dirty="0"/>
-          </a:p>
-        </p:txBody>
-      </p:sp>
-      <p:sp>
-        <p:nvSpPr>
-          <p:cNvPr id="18" name="karte"/>
-          <p:cNvSpPr/>
-          <p:nvPr/>
-        </p:nvSpPr>
-        <p:spPr>
-          <a:xfrm>
-            <a:off x="6233008" y="3817620"/>
-            <a:ext cx="5410048" cy="2217420"/>
-          </a:xfrm>
-          <a:prstGeom prst="roundRect">
-            <a:avLst>
-              <a:gd name="adj" fmla="val 4948"/>
-            </a:avLst>
-          </a:prstGeom>
-          <a:solidFill>
-            <a:srgbClr val="F7F7F7"/>
-          </a:solidFill>
-          <a:ln w="12700">
-            <a:solidFill>
-              <a:srgbClr val="F7F7F7"/>
-            </a:solidFill>
-            <a:prstDash val="solid"/>
-          </a:ln>
-        </p:spPr>
-        <p:txBody>
-          <a:bodyPr/>
-          <a:lstStyle/>
-          <a:p>
-            <a:endParaRPr lang="de-DE"/>
-          </a:p>
-        </p:txBody>
-      </p:sp>
-      <p:sp>
-        <p:nvSpPr>
-          <p:cNvPr id="19" name="icon-kreis-FaDoorOpen"/>
-          <p:cNvSpPr/>
-          <p:nvPr/>
-        </p:nvSpPr>
-        <p:spPr>
-          <a:xfrm>
-            <a:off x="6507328" y="4091940"/>
-            <a:ext cx="640080" cy="640080"/>
-          </a:xfrm>
-          <a:prstGeom prst="ellipse">
-            <a:avLst/>
-          </a:prstGeom>
-          <a:solidFill>
-            <a:srgbClr val="006FAD"/>
-          </a:solidFill>
-          <a:ln w="12700">
-            <a:solidFill>
-              <a:srgbClr val="006FAD"/>
-            </a:solidFill>
-            <a:prstDash val="solid"/>
-          </a:ln>
-        </p:spPr>
-        <p:txBody>
-          <a:bodyPr/>
-          <a:lstStyle/>
-          <a:p>
-            <a:endParaRPr lang="de-DE"/>
-          </a:p>
-        </p:txBody>
-      </p:sp>
-      <p:pic>
-        <p:nvPicPr>
-          <p:cNvPr id="20" name="icon-FaDoorOpen" descr="C:\Users\Thanam\AppData\Local\Temp\claude\c--Projekt-Trainings-azure-basics-training\a7a6b8eb-22f3-4b42-aecc-5af05d1502b1\scratchpad\folien\assets\icons\FaDoorOpen.png"/>
-          <p:cNvPicPr>
-            <a:picLocks noChangeAspect="1"/>
-          </p:cNvPicPr>
-          <p:nvPr/>
-        </p:nvPicPr>
-        <p:blipFill>
-          <a:blip r:embed="rId6"/>
-          <a:stretch>
-            <a:fillRect/>
-          </a:stretch>
-        </p:blipFill>
-        <p:spPr>
-          <a:xfrm>
-            <a:off x="6660947" y="4245559"/>
-            <a:ext cx="332842" cy="332842"/>
-          </a:xfrm>
-          <a:prstGeom prst="rect">
-            <a:avLst/>
-          </a:prstGeom>
-        </p:spPr>
-      </p:pic>
-      <p:sp>
-        <p:nvSpPr>
-          <p:cNvPr id="21" name="Text 15"/>
-          <p:cNvSpPr txBox="1"/>
-          <p:nvPr/>
-        </p:nvSpPr>
-        <p:spPr>
-          <a:xfrm>
-            <a:off x="7330288" y="4091940"/>
-            <a:ext cx="4084168" cy="640080"/>
-          </a:xfrm>
-          <a:prstGeom prst="rect">
-            <a:avLst/>
-          </a:prstGeom>
-          <a:noFill/>
-          <a:ln/>
-        </p:spPr>
-        <p:txBody>
-          <a:bodyPr wrap="square" lIns="0" tIns="0" rIns="0" bIns="0" rtlCol="0" anchor="ctr">
-            <a:normAutofit/>
-          </a:bodyPr>
-          <a:lstStyle/>
-          <a:p>
-            <a:pPr marL="0" indent="0">
-              <a:buNone/>
-            </a:pPr>
-            <a:r>
-              <a:rPr lang="en-US" sz="2000" b="1" dirty="0">
-                <a:solidFill>
-                  <a:srgbClr val="27303A"/>
-                </a:solidFill>
-              </a:rPr>
-              <a:t>Exit-Ticket</a:t>
-            </a:r>
-            <a:endParaRPr lang="en-US" sz="2000" dirty="0"/>
-          </a:p>
-        </p:txBody>
-      </p:sp>
-      <p:sp>
-        <p:nvSpPr>
-          <p:cNvPr id="22" name="Text 16"/>
-          <p:cNvSpPr txBox="1"/>
-          <p:nvPr/>
-        </p:nvSpPr>
-        <p:spPr>
-          <a:xfrm>
-            <a:off x="6507328" y="4914900"/>
-            <a:ext cx="4861408" cy="982980"/>
-          </a:xfrm>
-          <a:prstGeom prst="rect">
-            <a:avLst/>
-          </a:prstGeom>
-          <a:noFill/>
-          <a:ln/>
-        </p:spPr>
-        <p:txBody>
-          <a:bodyPr wrap="square" lIns="0" tIns="0" rIns="0" bIns="0" rtlCol="0" anchor="t"/>
-          <a:lstStyle/>
-          <a:p>
-            <a:pPr marL="0" indent="0">
-              <a:spcAft>
-                <a:spcPts val="400"/>
-              </a:spcAft>
-              <a:buNone/>
-            </a:pPr>
-            <a:r>
-              <a:rPr lang="en-US" sz="1600" dirty="0">
-                <a:solidFill>
-                  <a:srgbClr val="27303A"/>
-                </a:solidFill>
-              </a:rPr>
-              <a:t>Am Ende jedes Tages eine kurze Frage, 1–3 Sätze. Keine Note.</a:t>
-            </a:r>
-            <a:endParaRPr lang="en-US" sz="1600" dirty="0"/>
-          </a:p>
-        </p:txBody>
-      </p:sp>
-      <p:sp>
-        <p:nvSpPr>
-          <p:cNvPr id="25" name="Slide Number Placeholder 0"/>
-          <p:cNvSpPr>
-            <a:spLocks noGrp="1"/>
-          </p:cNvSpPr>
-          <p:nvPr>
-            <p:ph type="sldNum" sz="quarter" idx="4294967295"/>
-          </p:nvPr>
-        </p:nvSpPr>
-        <p:spPr>
-          <a:xfrm>
-            <a:off x="11183112" y="6336792"/>
-            <a:ext cx="457200" cy="365760"/>
-          </a:xfrm>
-          <a:prstGeom prst="rect">
-            <a:avLst/>
-          </a:prstGeom>
-          <a:extLst>
-            <a:ext uri="{C572A759-6A51-4108-AA02-DFA0A04FC94B}">
-              <ma14:wrappingTextBoxFlag xmlns:ma14="http://schemas.microsoft.com/office/mac/drawingml/2011/main" xmlns="" val="0"/>
+              <ma14:wrappingTextBoxFlag xmlns="" xmlns:ma14="http://schemas.microsoft.com/office/mac/drawingml/2011/main" val="0"/>
             </a:ext>
           </a:extLst>
         </p:spPr>
@@ -9910,7 +10005,7 @@
 
 <file path=ppt/webextensions/taskpanes.xml><?xml version="1.0" encoding="utf-8"?>
 <wetp:taskpanes xmlns:wetp="http://schemas.microsoft.com/office/webextensions/taskpanes/2010/11">
-  <wetp:taskpane dockstate="right" visibility="0" width="350" row="2">
+  <wetp:taskpane dockstate="right" visibility="0" width="350" row="1">
     <wetp:webextensionref xmlns:r="http://schemas.openxmlformats.org/officeDocument/2006/relationships" r:id="rId1"/>
   </wetp:taskpane>
 </wetp:taskpanes>

</xml_diff>